<commit_message>
Removed .git folder in code file
</commit_message>
<xml_diff>
--- a/week1readings.pptx
+++ b/week1readings.pptx
@@ -516,13 +516,6 @@
           </p:nvPr>
         </p:nvSpPr>
         <p:spPr/>
-        <p:txBody>
-          <a:bodyPr/>
-          <a:lstStyle/>
-          <a:p>
-            <a:endParaRPr lang="en-US"/>
-          </a:p>
-        </p:txBody>
       </p:sp>
       <p:sp>
         <p:nvSpPr>
@@ -539,7 +532,34 @@
           <a:bodyPr/>
           <a:lstStyle/>
           <a:p>
-            <a:endParaRPr lang="en-US" dirty="0"/>
+            <a:pPr marL="171450" indent="-171450">
+              <a:buFontTx/>
+              <a:buChar char="-"/>
+            </a:pPr>
+            <a:r>
+              <a:rPr lang="en-US" dirty="0"/>
+              <a:t>A mesh network is effectively a decentralized network where nodes connect to as many other nodes as possible to efficiently send data</a:t>
+            </a:r>
+          </a:p>
+          <a:p>
+            <a:pPr marL="171450" indent="-171450">
+              <a:buFontTx/>
+              <a:buChar char="-"/>
+            </a:pPr>
+            <a:r>
+              <a:rPr lang="en-US" dirty="0"/>
+              <a:t>LoRa is a wireless radio technology which is designed for long range communication and low power consumption</a:t>
+            </a:r>
+          </a:p>
+          <a:p>
+            <a:pPr marL="628650" lvl="1" indent="-171450">
+              <a:buFontTx/>
+              <a:buChar char="-"/>
+            </a:pPr>
+            <a:r>
+              <a:rPr lang="en-US" dirty="0"/>
+              <a:t>It is for this reason that LoRa is good for IoT devices</a:t>
+            </a:r>
           </a:p>
         </p:txBody>
       </p:sp>
@@ -560,7 +580,7 @@
           <a:p>
             <a:fld id="{96753925-02D2-5745-BCE6-069A285A2A4E}" type="slidenum">
               <a:rPr lang="en-US" smtClean="0"/>
-              <a:t>10</a:t>
+              <a:t>3</a:t>
             </a:fld>
             <a:endParaRPr lang="en-US"/>
           </a:p>
@@ -569,7 +589,875 @@
     </p:spTree>
     <p:extLst>
       <p:ext uri="{BB962C8B-B14F-4D97-AF65-F5344CB8AC3E}">
-        <p14:creationId xmlns:p14="http://schemas.microsoft.com/office/powerpoint/2010/main" val="702400172"/>
+        <p14:creationId xmlns:p14="http://schemas.microsoft.com/office/powerpoint/2010/main" val="648380830"/>
+      </p:ext>
+    </p:extLst>
+  </p:cSld>
+  <p:clrMapOvr>
+    <a:masterClrMapping/>
+  </p:clrMapOvr>
+</p:notes>
+</file>
+
+<file path=ppt/notesSlides/notesSlide10.xml><?xml version="1.0" encoding="utf-8"?>
+<p:notes xmlns:a="http://schemas.openxmlformats.org/drawingml/2006/main" xmlns:r="http://schemas.openxmlformats.org/officeDocument/2006/relationships" xmlns:p="http://schemas.openxmlformats.org/presentationml/2006/main">
+  <p:cSld>
+    <p:spTree>
+      <p:nvGrpSpPr>
+        <p:cNvPr id="1" name=""/>
+        <p:cNvGrpSpPr/>
+        <p:nvPr/>
+      </p:nvGrpSpPr>
+      <p:grpSpPr>
+        <a:xfrm>
+          <a:off x="0" y="0"/>
+          <a:ext cx="0" cy="0"/>
+          <a:chOff x="0" y="0"/>
+          <a:chExt cx="0" cy="0"/>
+        </a:xfrm>
+      </p:grpSpPr>
+      <p:sp>
+        <p:nvSpPr>
+          <p:cNvPr id="2" name="Slide Image Placeholder 1"/>
+          <p:cNvSpPr>
+            <a:spLocks noGrp="1" noRot="1" noChangeAspect="1"/>
+          </p:cNvSpPr>
+          <p:nvPr>
+            <p:ph type="sldImg"/>
+          </p:nvPr>
+        </p:nvSpPr>
+        <p:spPr/>
+      </p:sp>
+      <p:sp>
+        <p:nvSpPr>
+          <p:cNvPr id="3" name="Notes Placeholder 2"/>
+          <p:cNvSpPr>
+            <a:spLocks noGrp="1"/>
+          </p:cNvSpPr>
+          <p:nvPr>
+            <p:ph type="body" idx="1"/>
+          </p:nvPr>
+        </p:nvSpPr>
+        <p:spPr/>
+        <p:txBody>
+          <a:bodyPr/>
+          <a:lstStyle/>
+          <a:p>
+            <a:pPr marL="171450" indent="-171450">
+              <a:buFontTx/>
+              <a:buChar char="-"/>
+            </a:pPr>
+            <a:r>
+              <a:rPr lang="en-US" dirty="0"/>
+              <a:t>As hop count increases, managed flooding becomes highly airtime intensive. More nodes rebroadcasting results in more redundant transmissions</a:t>
+            </a:r>
+          </a:p>
+          <a:p>
+            <a:pPr marL="171450" indent="-171450">
+              <a:buFontTx/>
+              <a:buChar char="-"/>
+            </a:pPr>
+            <a:r>
+              <a:rPr lang="en-US" dirty="0"/>
+              <a:t>Thus, Meshtastic has its max hops set to 7 while MeshCore is at 64. This allows for longer potential routed</a:t>
+            </a:r>
+          </a:p>
+          <a:p>
+            <a:pPr marL="171450" indent="-171450">
+              <a:buFontTx/>
+              <a:buChar char="-"/>
+            </a:pPr>
+            <a:r>
+              <a:rPr lang="en-US" dirty="0"/>
+              <a:t>As stated previously, Meshtastic nodes can move around and performance stay the same. MeshCore cannot do this, as moving repeaters will break routes</a:t>
+            </a:r>
+          </a:p>
+          <a:p>
+            <a:pPr marL="171450" indent="-171450">
+              <a:buFontTx/>
+              <a:buChar char="-"/>
+            </a:pPr>
+            <a:r>
+              <a:rPr lang="en-US" dirty="0"/>
+              <a:t>Additionally, Meshtastic has more supported hardware, docs and telemetry</a:t>
+            </a:r>
+          </a:p>
+          <a:p>
+            <a:pPr marL="171450" indent="-171450">
+              <a:buFontTx/>
+              <a:buChar char="-"/>
+            </a:pPr>
+            <a:r>
+              <a:rPr lang="en-US" dirty="0"/>
+              <a:t>Meshtastic is simple, versatile and best for mobile, group, off-grid communication. MeshCore is best for stationary meshes focused on optimizing performance</a:t>
+            </a:r>
+          </a:p>
+        </p:txBody>
+      </p:sp>
+      <p:sp>
+        <p:nvSpPr>
+          <p:cNvPr id="4" name="Slide Number Placeholder 3"/>
+          <p:cNvSpPr>
+            <a:spLocks noGrp="1"/>
+          </p:cNvSpPr>
+          <p:nvPr>
+            <p:ph type="sldNum" sz="quarter" idx="5"/>
+          </p:nvPr>
+        </p:nvSpPr>
+        <p:spPr/>
+        <p:txBody>
+          <a:bodyPr/>
+          <a:lstStyle/>
+          <a:p>
+            <a:fld id="{96753925-02D2-5745-BCE6-069A285A2A4E}" type="slidenum">
+              <a:rPr lang="en-US" smtClean="0"/>
+              <a:t>14</a:t>
+            </a:fld>
+            <a:endParaRPr lang="en-US"/>
+          </a:p>
+        </p:txBody>
+      </p:sp>
+    </p:spTree>
+    <p:extLst>
+      <p:ext uri="{BB962C8B-B14F-4D97-AF65-F5344CB8AC3E}">
+        <p14:creationId xmlns:p14="http://schemas.microsoft.com/office/powerpoint/2010/main" val="564700070"/>
+      </p:ext>
+    </p:extLst>
+  </p:cSld>
+  <p:clrMapOvr>
+    <a:masterClrMapping/>
+  </p:clrMapOvr>
+</p:notes>
+</file>
+
+<file path=ppt/notesSlides/notesSlide11.xml><?xml version="1.0" encoding="utf-8"?>
+<p:notes xmlns:a="http://schemas.openxmlformats.org/drawingml/2006/main" xmlns:r="http://schemas.openxmlformats.org/officeDocument/2006/relationships" xmlns:p="http://schemas.openxmlformats.org/presentationml/2006/main">
+  <p:cSld>
+    <p:spTree>
+      <p:nvGrpSpPr>
+        <p:cNvPr id="1" name=""/>
+        <p:cNvGrpSpPr/>
+        <p:nvPr/>
+      </p:nvGrpSpPr>
+      <p:grpSpPr>
+        <a:xfrm>
+          <a:off x="0" y="0"/>
+          <a:ext cx="0" cy="0"/>
+          <a:chOff x="0" y="0"/>
+          <a:chExt cx="0" cy="0"/>
+        </a:xfrm>
+      </p:grpSpPr>
+      <p:sp>
+        <p:nvSpPr>
+          <p:cNvPr id="2" name="Slide Image Placeholder 1"/>
+          <p:cNvSpPr>
+            <a:spLocks noGrp="1" noRot="1" noChangeAspect="1"/>
+          </p:cNvSpPr>
+          <p:nvPr>
+            <p:ph type="sldImg"/>
+          </p:nvPr>
+        </p:nvSpPr>
+        <p:spPr/>
+      </p:sp>
+      <p:sp>
+        <p:nvSpPr>
+          <p:cNvPr id="3" name="Notes Placeholder 2"/>
+          <p:cNvSpPr>
+            <a:spLocks noGrp="1"/>
+          </p:cNvSpPr>
+          <p:nvPr>
+            <p:ph type="body" idx="1"/>
+          </p:nvPr>
+        </p:nvSpPr>
+        <p:spPr/>
+        <p:txBody>
+          <a:bodyPr/>
+          <a:lstStyle/>
+          <a:p>
+            <a:pPr marL="171450" indent="-171450">
+              <a:buFontTx/>
+              <a:buChar char="-"/>
+            </a:pPr>
+            <a:r>
+              <a:rPr lang="en-US" dirty="0"/>
+              <a:t>Meshtastic and MeshCore encryption is very similar.</a:t>
+            </a:r>
+          </a:p>
+          <a:p>
+            <a:pPr marL="171450" indent="-171450">
+              <a:buFontTx/>
+              <a:buChar char="-"/>
+            </a:pPr>
+            <a:r>
+              <a:rPr lang="en-US" dirty="0"/>
+              <a:t>The main difference between the two is that Meshtastic uses AES-256 (CTR) while MeshCore uses AES-128. Regardless, both are still very secure</a:t>
+            </a:r>
+          </a:p>
+          <a:p>
+            <a:pPr marL="171450" indent="-171450">
+              <a:buFontTx/>
+              <a:buChar char="-"/>
+            </a:pPr>
+            <a:r>
+              <a:rPr lang="en-US" dirty="0"/>
+              <a:t>In both systems, channels are securing using a pre-shared key, meaning every node in the channel (including intermediate nodes) have access to the channel key.</a:t>
+            </a:r>
+          </a:p>
+          <a:p>
+            <a:pPr marL="628650" lvl="1" indent="-171450">
+              <a:buFontTx/>
+              <a:buChar char="-"/>
+            </a:pPr>
+            <a:r>
+              <a:rPr lang="en-US" dirty="0"/>
+              <a:t>Thus, it is a bad idea to share private data in channels while leaving receiver or intermediate nodes unattended</a:t>
+            </a:r>
+          </a:p>
+          <a:p>
+            <a:pPr marL="171450" lvl="0" indent="-171450">
+              <a:buFontTx/>
+              <a:buChar char="-"/>
+            </a:pPr>
+            <a:r>
+              <a:rPr lang="en-US" dirty="0"/>
+              <a:t>Also in both systems, DMs are encrypted using Public Key Cryptography. Only senders and receivers have private keys, blocking intermediate nodes from access</a:t>
+            </a:r>
+          </a:p>
+        </p:txBody>
+      </p:sp>
+      <p:sp>
+        <p:nvSpPr>
+          <p:cNvPr id="4" name="Slide Number Placeholder 3"/>
+          <p:cNvSpPr>
+            <a:spLocks noGrp="1"/>
+          </p:cNvSpPr>
+          <p:nvPr>
+            <p:ph type="sldNum" sz="quarter" idx="5"/>
+          </p:nvPr>
+        </p:nvSpPr>
+        <p:spPr/>
+        <p:txBody>
+          <a:bodyPr/>
+          <a:lstStyle/>
+          <a:p>
+            <a:fld id="{96753925-02D2-5745-BCE6-069A285A2A4E}" type="slidenum">
+              <a:rPr lang="en-US" smtClean="0"/>
+              <a:t>16</a:t>
+            </a:fld>
+            <a:endParaRPr lang="en-US"/>
+          </a:p>
+        </p:txBody>
+      </p:sp>
+    </p:spTree>
+    <p:extLst>
+      <p:ext uri="{BB962C8B-B14F-4D97-AF65-F5344CB8AC3E}">
+        <p14:creationId xmlns:p14="http://schemas.microsoft.com/office/powerpoint/2010/main" val="975279094"/>
+      </p:ext>
+    </p:extLst>
+  </p:cSld>
+  <p:clrMapOvr>
+    <a:masterClrMapping/>
+  </p:clrMapOvr>
+</p:notes>
+</file>
+
+<file path=ppt/notesSlides/notesSlide12.xml><?xml version="1.0" encoding="utf-8"?>
+<p:notes xmlns:a="http://schemas.openxmlformats.org/drawingml/2006/main" xmlns:r="http://schemas.openxmlformats.org/officeDocument/2006/relationships" xmlns:p="http://schemas.openxmlformats.org/presentationml/2006/main">
+  <p:cSld>
+    <p:spTree>
+      <p:nvGrpSpPr>
+        <p:cNvPr id="1" name=""/>
+        <p:cNvGrpSpPr/>
+        <p:nvPr/>
+      </p:nvGrpSpPr>
+      <p:grpSpPr>
+        <a:xfrm>
+          <a:off x="0" y="0"/>
+          <a:ext cx="0" cy="0"/>
+          <a:chOff x="0" y="0"/>
+          <a:chExt cx="0" cy="0"/>
+        </a:xfrm>
+      </p:grpSpPr>
+      <p:sp>
+        <p:nvSpPr>
+          <p:cNvPr id="2" name="Slide Image Placeholder 1"/>
+          <p:cNvSpPr>
+            <a:spLocks noGrp="1" noRot="1" noChangeAspect="1"/>
+          </p:cNvSpPr>
+          <p:nvPr>
+            <p:ph type="sldImg"/>
+          </p:nvPr>
+        </p:nvSpPr>
+        <p:spPr/>
+      </p:sp>
+      <p:sp>
+        <p:nvSpPr>
+          <p:cNvPr id="3" name="Notes Placeholder 2"/>
+          <p:cNvSpPr>
+            <a:spLocks noGrp="1"/>
+          </p:cNvSpPr>
+          <p:nvPr>
+            <p:ph type="body" idx="1"/>
+          </p:nvPr>
+        </p:nvSpPr>
+        <p:spPr/>
+        <p:txBody>
+          <a:bodyPr/>
+          <a:lstStyle/>
+          <a:p>
+            <a:r>
+              <a:rPr lang="en-US" dirty="0"/>
+              <a:t>- The Meshtastic site and docs are by far the best Meshtastic resource for anything Meshtastic. This is more or less the only Meshtastic site I frequently refer to</a:t>
+            </a:r>
+          </a:p>
+        </p:txBody>
+      </p:sp>
+      <p:sp>
+        <p:nvSpPr>
+          <p:cNvPr id="4" name="Slide Number Placeholder 3"/>
+          <p:cNvSpPr>
+            <a:spLocks noGrp="1"/>
+          </p:cNvSpPr>
+          <p:nvPr>
+            <p:ph type="sldNum" sz="quarter" idx="5"/>
+          </p:nvPr>
+        </p:nvSpPr>
+        <p:spPr/>
+        <p:txBody>
+          <a:bodyPr/>
+          <a:lstStyle/>
+          <a:p>
+            <a:fld id="{96753925-02D2-5745-BCE6-069A285A2A4E}" type="slidenum">
+              <a:rPr lang="en-US" smtClean="0"/>
+              <a:t>19</a:t>
+            </a:fld>
+            <a:endParaRPr lang="en-US"/>
+          </a:p>
+        </p:txBody>
+      </p:sp>
+    </p:spTree>
+    <p:extLst>
+      <p:ext uri="{BB962C8B-B14F-4D97-AF65-F5344CB8AC3E}">
+        <p14:creationId xmlns:p14="http://schemas.microsoft.com/office/powerpoint/2010/main" val="3545223882"/>
+      </p:ext>
+    </p:extLst>
+  </p:cSld>
+  <p:clrMapOvr>
+    <a:masterClrMapping/>
+  </p:clrMapOvr>
+</p:notes>
+</file>
+
+<file path=ppt/notesSlides/notesSlide13.xml><?xml version="1.0" encoding="utf-8"?>
+<p:notes xmlns:a="http://schemas.openxmlformats.org/drawingml/2006/main" xmlns:r="http://schemas.openxmlformats.org/officeDocument/2006/relationships" xmlns:p="http://schemas.openxmlformats.org/presentationml/2006/main">
+  <p:cSld>
+    <p:spTree>
+      <p:nvGrpSpPr>
+        <p:cNvPr id="1" name=""/>
+        <p:cNvGrpSpPr/>
+        <p:nvPr/>
+      </p:nvGrpSpPr>
+      <p:grpSpPr>
+        <a:xfrm>
+          <a:off x="0" y="0"/>
+          <a:ext cx="0" cy="0"/>
+          <a:chOff x="0" y="0"/>
+          <a:chExt cx="0" cy="0"/>
+        </a:xfrm>
+      </p:grpSpPr>
+      <p:sp>
+        <p:nvSpPr>
+          <p:cNvPr id="2" name="Slide Image Placeholder 1"/>
+          <p:cNvSpPr>
+            <a:spLocks noGrp="1" noRot="1" noChangeAspect="1"/>
+          </p:cNvSpPr>
+          <p:nvPr>
+            <p:ph type="sldImg"/>
+          </p:nvPr>
+        </p:nvSpPr>
+        <p:spPr/>
+      </p:sp>
+      <p:sp>
+        <p:nvSpPr>
+          <p:cNvPr id="3" name="Notes Placeholder 2"/>
+          <p:cNvSpPr>
+            <a:spLocks noGrp="1"/>
+          </p:cNvSpPr>
+          <p:nvPr>
+            <p:ph type="body" idx="1"/>
+          </p:nvPr>
+        </p:nvSpPr>
+        <p:spPr/>
+        <p:txBody>
+          <a:bodyPr/>
+          <a:lstStyle/>
+          <a:p>
+            <a:r>
+              <a:rPr lang="en-US" dirty="0"/>
+              <a:t>The MeshCore site is good but the docs are not as in depth</a:t>
+            </a:r>
+          </a:p>
+          <a:p>
+            <a:r>
+              <a:rPr lang="en-US" dirty="0"/>
+              <a:t>There really isn’t documentation but they have a giant FAQ page covering many </a:t>
+            </a:r>
+            <a:r>
+              <a:rPr lang="en-US" dirty="0" err="1"/>
+              <a:t>importqnt</a:t>
+            </a:r>
+            <a:r>
+              <a:rPr lang="en-US" dirty="0"/>
+              <a:t> details.</a:t>
+            </a:r>
+          </a:p>
+          <a:p>
+            <a:r>
+              <a:rPr lang="en-US" dirty="0"/>
+              <a:t>I find I have to use 3</a:t>
+            </a:r>
+            <a:r>
+              <a:rPr lang="en-US" baseline="30000" dirty="0"/>
+              <a:t>rd</a:t>
+            </a:r>
+            <a:r>
+              <a:rPr lang="en-US" dirty="0"/>
+              <a:t> party sources more often with MeshCore. This one is by … my </a:t>
+            </a:r>
+            <a:r>
+              <a:rPr lang="en-US" dirty="0" err="1"/>
+              <a:t>favousite</a:t>
+            </a:r>
+            <a:endParaRPr lang="en-US" dirty="0"/>
+          </a:p>
+        </p:txBody>
+      </p:sp>
+      <p:sp>
+        <p:nvSpPr>
+          <p:cNvPr id="4" name="Slide Number Placeholder 3"/>
+          <p:cNvSpPr>
+            <a:spLocks noGrp="1"/>
+          </p:cNvSpPr>
+          <p:nvPr>
+            <p:ph type="sldNum" sz="quarter" idx="5"/>
+          </p:nvPr>
+        </p:nvSpPr>
+        <p:spPr/>
+        <p:txBody>
+          <a:bodyPr/>
+          <a:lstStyle/>
+          <a:p>
+            <a:fld id="{96753925-02D2-5745-BCE6-069A285A2A4E}" type="slidenum">
+              <a:rPr lang="en-US" smtClean="0"/>
+              <a:t>20</a:t>
+            </a:fld>
+            <a:endParaRPr lang="en-US"/>
+          </a:p>
+        </p:txBody>
+      </p:sp>
+    </p:spTree>
+    <p:extLst>
+      <p:ext uri="{BB962C8B-B14F-4D97-AF65-F5344CB8AC3E}">
+        <p14:creationId xmlns:p14="http://schemas.microsoft.com/office/powerpoint/2010/main" val="471049221"/>
+      </p:ext>
+    </p:extLst>
+  </p:cSld>
+  <p:clrMapOvr>
+    <a:masterClrMapping/>
+  </p:clrMapOvr>
+</p:notes>
+</file>
+
+<file path=ppt/notesSlides/notesSlide14.xml><?xml version="1.0" encoding="utf-8"?>
+<p:notes xmlns:a="http://schemas.openxmlformats.org/drawingml/2006/main" xmlns:r="http://schemas.openxmlformats.org/officeDocument/2006/relationships" xmlns:p="http://schemas.openxmlformats.org/presentationml/2006/main">
+  <p:cSld>
+    <p:spTree>
+      <p:nvGrpSpPr>
+        <p:cNvPr id="1" name=""/>
+        <p:cNvGrpSpPr/>
+        <p:nvPr/>
+      </p:nvGrpSpPr>
+      <p:grpSpPr>
+        <a:xfrm>
+          <a:off x="0" y="0"/>
+          <a:ext cx="0" cy="0"/>
+          <a:chOff x="0" y="0"/>
+          <a:chExt cx="0" cy="0"/>
+        </a:xfrm>
+      </p:grpSpPr>
+      <p:sp>
+        <p:nvSpPr>
+          <p:cNvPr id="2" name="Slide Image Placeholder 1"/>
+          <p:cNvSpPr>
+            <a:spLocks noGrp="1" noRot="1" noChangeAspect="1"/>
+          </p:cNvSpPr>
+          <p:nvPr>
+            <p:ph type="sldImg"/>
+          </p:nvPr>
+        </p:nvSpPr>
+        <p:spPr/>
+      </p:sp>
+      <p:sp>
+        <p:nvSpPr>
+          <p:cNvPr id="3" name="Notes Placeholder 2"/>
+          <p:cNvSpPr>
+            <a:spLocks noGrp="1"/>
+          </p:cNvSpPr>
+          <p:nvPr>
+            <p:ph type="body" idx="1"/>
+          </p:nvPr>
+        </p:nvSpPr>
+        <p:spPr/>
+        <p:txBody>
+          <a:bodyPr/>
+          <a:lstStyle/>
+          <a:p>
+            <a:r>
+              <a:rPr lang="en-US" dirty="0"/>
+              <a:t>The web flasher is very self explanatory – it makes flashing firmware onto devices very simple. Both websites are east to use and give instructions with how to flash</a:t>
+            </a:r>
+          </a:p>
+        </p:txBody>
+      </p:sp>
+      <p:sp>
+        <p:nvSpPr>
+          <p:cNvPr id="4" name="Slide Number Placeholder 3"/>
+          <p:cNvSpPr>
+            <a:spLocks noGrp="1"/>
+          </p:cNvSpPr>
+          <p:nvPr>
+            <p:ph type="sldNum" sz="quarter" idx="5"/>
+          </p:nvPr>
+        </p:nvSpPr>
+        <p:spPr/>
+        <p:txBody>
+          <a:bodyPr/>
+          <a:lstStyle/>
+          <a:p>
+            <a:fld id="{96753925-02D2-5745-BCE6-069A285A2A4E}" type="slidenum">
+              <a:rPr lang="en-US" smtClean="0"/>
+              <a:t>21</a:t>
+            </a:fld>
+            <a:endParaRPr lang="en-US"/>
+          </a:p>
+        </p:txBody>
+      </p:sp>
+    </p:spTree>
+    <p:extLst>
+      <p:ext uri="{BB962C8B-B14F-4D97-AF65-F5344CB8AC3E}">
+        <p14:creationId xmlns:p14="http://schemas.microsoft.com/office/powerpoint/2010/main" val="3664646264"/>
+      </p:ext>
+    </p:extLst>
+  </p:cSld>
+  <p:clrMapOvr>
+    <a:masterClrMapping/>
+  </p:clrMapOvr>
+</p:notes>
+</file>
+
+<file path=ppt/notesSlides/notesSlide15.xml><?xml version="1.0" encoding="utf-8"?>
+<p:notes xmlns:a="http://schemas.openxmlformats.org/drawingml/2006/main" xmlns:r="http://schemas.openxmlformats.org/officeDocument/2006/relationships" xmlns:p="http://schemas.openxmlformats.org/presentationml/2006/main">
+  <p:cSld>
+    <p:spTree>
+      <p:nvGrpSpPr>
+        <p:cNvPr id="1" name=""/>
+        <p:cNvGrpSpPr/>
+        <p:nvPr/>
+      </p:nvGrpSpPr>
+      <p:grpSpPr>
+        <a:xfrm>
+          <a:off x="0" y="0"/>
+          <a:ext cx="0" cy="0"/>
+          <a:chOff x="0" y="0"/>
+          <a:chExt cx="0" cy="0"/>
+        </a:xfrm>
+      </p:grpSpPr>
+      <p:sp>
+        <p:nvSpPr>
+          <p:cNvPr id="2" name="Slide Image Placeholder 1"/>
+          <p:cNvSpPr>
+            <a:spLocks noGrp="1" noRot="1" noChangeAspect="1"/>
+          </p:cNvSpPr>
+          <p:nvPr>
+            <p:ph type="sldImg"/>
+          </p:nvPr>
+        </p:nvSpPr>
+        <p:spPr/>
+      </p:sp>
+      <p:sp>
+        <p:nvSpPr>
+          <p:cNvPr id="3" name="Notes Placeholder 2"/>
+          <p:cNvSpPr>
+            <a:spLocks noGrp="1"/>
+          </p:cNvSpPr>
+          <p:nvPr>
+            <p:ph type="body" idx="1"/>
+          </p:nvPr>
+        </p:nvSpPr>
+        <p:spPr/>
+        <p:txBody>
+          <a:bodyPr/>
+          <a:lstStyle/>
+          <a:p>
+            <a:r>
+              <a:rPr lang="en-US" dirty="0"/>
+              <a:t>- The GitHub is also worth noting – very important for questions regarding specific implementation and  development</a:t>
+            </a:r>
+          </a:p>
+        </p:txBody>
+      </p:sp>
+      <p:sp>
+        <p:nvSpPr>
+          <p:cNvPr id="4" name="Slide Number Placeholder 3"/>
+          <p:cNvSpPr>
+            <a:spLocks noGrp="1"/>
+          </p:cNvSpPr>
+          <p:nvPr>
+            <p:ph type="sldNum" sz="quarter" idx="5"/>
+          </p:nvPr>
+        </p:nvSpPr>
+        <p:spPr/>
+        <p:txBody>
+          <a:bodyPr/>
+          <a:lstStyle/>
+          <a:p>
+            <a:fld id="{96753925-02D2-5745-BCE6-069A285A2A4E}" type="slidenum">
+              <a:rPr lang="en-US" smtClean="0"/>
+              <a:t>22</a:t>
+            </a:fld>
+            <a:endParaRPr lang="en-US"/>
+          </a:p>
+        </p:txBody>
+      </p:sp>
+    </p:spTree>
+    <p:extLst>
+      <p:ext uri="{BB962C8B-B14F-4D97-AF65-F5344CB8AC3E}">
+        <p14:creationId xmlns:p14="http://schemas.microsoft.com/office/powerpoint/2010/main" val="397236402"/>
+      </p:ext>
+    </p:extLst>
+  </p:cSld>
+  <p:clrMapOvr>
+    <a:masterClrMapping/>
+  </p:clrMapOvr>
+</p:notes>
+</file>
+
+<file path=ppt/notesSlides/notesSlide16.xml><?xml version="1.0" encoding="utf-8"?>
+<p:notes xmlns:a="http://schemas.openxmlformats.org/drawingml/2006/main" xmlns:r="http://schemas.openxmlformats.org/officeDocument/2006/relationships" xmlns:p="http://schemas.openxmlformats.org/presentationml/2006/main">
+  <p:cSld>
+    <p:spTree>
+      <p:nvGrpSpPr>
+        <p:cNvPr id="1" name=""/>
+        <p:cNvGrpSpPr/>
+        <p:nvPr/>
+      </p:nvGrpSpPr>
+      <p:grpSpPr>
+        <a:xfrm>
+          <a:off x="0" y="0"/>
+          <a:ext cx="0" cy="0"/>
+          <a:chOff x="0" y="0"/>
+          <a:chExt cx="0" cy="0"/>
+        </a:xfrm>
+      </p:grpSpPr>
+      <p:sp>
+        <p:nvSpPr>
+          <p:cNvPr id="2" name="Slide Image Placeholder 1"/>
+          <p:cNvSpPr>
+            <a:spLocks noGrp="1" noRot="1" noChangeAspect="1"/>
+          </p:cNvSpPr>
+          <p:nvPr>
+            <p:ph type="sldImg"/>
+          </p:nvPr>
+        </p:nvSpPr>
+        <p:spPr/>
+      </p:sp>
+      <p:sp>
+        <p:nvSpPr>
+          <p:cNvPr id="3" name="Notes Placeholder 2"/>
+          <p:cNvSpPr>
+            <a:spLocks noGrp="1"/>
+          </p:cNvSpPr>
+          <p:nvPr>
+            <p:ph type="body" idx="1"/>
+          </p:nvPr>
+        </p:nvSpPr>
+        <p:spPr/>
+        <p:txBody>
+          <a:bodyPr/>
+          <a:lstStyle/>
+          <a:p>
+            <a:pPr marL="171450" indent="-171450">
+              <a:buFontTx/>
+              <a:buChar char="-"/>
+            </a:pPr>
+            <a:r>
+              <a:rPr lang="en-US" dirty="0"/>
+              <a:t>These first two articles were my </a:t>
+            </a:r>
+            <a:r>
+              <a:rPr lang="en-US" dirty="0" err="1"/>
+              <a:t>favourite</a:t>
+            </a:r>
+            <a:r>
+              <a:rPr lang="en-US" dirty="0"/>
+              <a:t> Meshtastic how-</a:t>
+            </a:r>
+            <a:r>
+              <a:rPr lang="en-US" dirty="0" err="1"/>
+              <a:t>tos</a:t>
+            </a:r>
+            <a:r>
+              <a:rPr lang="en-US" dirty="0"/>
+              <a:t>, specifically the dev.to one. They keep things very simple</a:t>
+            </a:r>
+          </a:p>
+          <a:p>
+            <a:pPr marL="171450" indent="-171450">
+              <a:buFontTx/>
+              <a:buChar char="-"/>
+            </a:pPr>
+            <a:r>
+              <a:rPr lang="en-US" dirty="0"/>
+              <a:t>The Kindlymorrow what is MeshCore article was super helpful –they explain clearly the architectural differences between Meshtastic and MeshCore and when to use each</a:t>
+            </a:r>
+          </a:p>
+        </p:txBody>
+      </p:sp>
+      <p:sp>
+        <p:nvSpPr>
+          <p:cNvPr id="4" name="Slide Number Placeholder 3"/>
+          <p:cNvSpPr>
+            <a:spLocks noGrp="1"/>
+          </p:cNvSpPr>
+          <p:nvPr>
+            <p:ph type="sldNum" sz="quarter" idx="5"/>
+          </p:nvPr>
+        </p:nvSpPr>
+        <p:spPr/>
+        <p:txBody>
+          <a:bodyPr/>
+          <a:lstStyle/>
+          <a:p>
+            <a:fld id="{96753925-02D2-5745-BCE6-069A285A2A4E}" type="slidenum">
+              <a:rPr lang="en-US" smtClean="0"/>
+              <a:t>23</a:t>
+            </a:fld>
+            <a:endParaRPr lang="en-US"/>
+          </a:p>
+        </p:txBody>
+      </p:sp>
+    </p:spTree>
+    <p:extLst>
+      <p:ext uri="{BB962C8B-B14F-4D97-AF65-F5344CB8AC3E}">
+        <p14:creationId xmlns:p14="http://schemas.microsoft.com/office/powerpoint/2010/main" val="2067899235"/>
+      </p:ext>
+    </p:extLst>
+  </p:cSld>
+  <p:clrMapOvr>
+    <a:masterClrMapping/>
+  </p:clrMapOvr>
+</p:notes>
+</file>
+
+<file path=ppt/notesSlides/notesSlide17.xml><?xml version="1.0" encoding="utf-8"?>
+<p:notes xmlns:a="http://schemas.openxmlformats.org/drawingml/2006/main" xmlns:r="http://schemas.openxmlformats.org/officeDocument/2006/relationships" xmlns:p="http://schemas.openxmlformats.org/presentationml/2006/main">
+  <p:cSld>
+    <p:spTree>
+      <p:nvGrpSpPr>
+        <p:cNvPr id="1" name=""/>
+        <p:cNvGrpSpPr/>
+        <p:nvPr/>
+      </p:nvGrpSpPr>
+      <p:grpSpPr>
+        <a:xfrm>
+          <a:off x="0" y="0"/>
+          <a:ext cx="0" cy="0"/>
+          <a:chOff x="0" y="0"/>
+          <a:chExt cx="0" cy="0"/>
+        </a:xfrm>
+      </p:grpSpPr>
+      <p:sp>
+        <p:nvSpPr>
+          <p:cNvPr id="2" name="Slide Image Placeholder 1"/>
+          <p:cNvSpPr>
+            <a:spLocks noGrp="1" noRot="1" noChangeAspect="1"/>
+          </p:cNvSpPr>
+          <p:nvPr>
+            <p:ph type="sldImg"/>
+          </p:nvPr>
+        </p:nvSpPr>
+        <p:spPr/>
+      </p:sp>
+      <p:sp>
+        <p:nvSpPr>
+          <p:cNvPr id="3" name="Notes Placeholder 2"/>
+          <p:cNvSpPr>
+            <a:spLocks noGrp="1"/>
+          </p:cNvSpPr>
+          <p:nvPr>
+            <p:ph type="body" idx="1"/>
+          </p:nvPr>
+        </p:nvSpPr>
+        <p:spPr/>
+        <p:txBody>
+          <a:bodyPr/>
+          <a:lstStyle/>
+          <a:p>
+            <a:pPr marL="171450" indent="-171450">
+              <a:buFontTx/>
+              <a:buChar char="-"/>
+            </a:pPr>
+            <a:r>
+              <a:rPr lang="en-US" dirty="0"/>
+              <a:t>These videos are good for helping people flash firmware for the first time.</a:t>
+            </a:r>
+          </a:p>
+          <a:p>
+            <a:pPr marL="171450" indent="-171450">
+              <a:buFontTx/>
+              <a:buChar char="-"/>
+            </a:pPr>
+            <a:r>
+              <a:rPr lang="en-US" dirty="0"/>
+              <a:t>The Meshtastic and LoRa are dangerous video was a great watch. It begun explaining meshes and LoRa at a high level, slowly diving into Meshtastic specifics like how Meshtastic takes advantage of MQTT servers and integrating sensors into </a:t>
+            </a:r>
+            <a:r>
+              <a:rPr lang="en-US"/>
+              <a:t>the mesh.</a:t>
+            </a:r>
+          </a:p>
+          <a:p>
+            <a:endParaRPr lang="en-US" dirty="0"/>
+          </a:p>
+        </p:txBody>
+      </p:sp>
+      <p:sp>
+        <p:nvSpPr>
+          <p:cNvPr id="4" name="Slide Number Placeholder 3"/>
+          <p:cNvSpPr>
+            <a:spLocks noGrp="1"/>
+          </p:cNvSpPr>
+          <p:nvPr>
+            <p:ph type="sldNum" sz="quarter" idx="5"/>
+          </p:nvPr>
+        </p:nvSpPr>
+        <p:spPr/>
+        <p:txBody>
+          <a:bodyPr/>
+          <a:lstStyle/>
+          <a:p>
+            <a:fld id="{96753925-02D2-5745-BCE6-069A285A2A4E}" type="slidenum">
+              <a:rPr lang="en-US" smtClean="0"/>
+              <a:t>24</a:t>
+            </a:fld>
+            <a:endParaRPr lang="en-US"/>
+          </a:p>
+        </p:txBody>
+      </p:sp>
+    </p:spTree>
+    <p:extLst>
+      <p:ext uri="{BB962C8B-B14F-4D97-AF65-F5344CB8AC3E}">
+        <p14:creationId xmlns:p14="http://schemas.microsoft.com/office/powerpoint/2010/main" val="4207248588"/>
       </p:ext>
     </p:extLst>
   </p:cSld>
@@ -623,7 +1511,76 @@
           <a:bodyPr/>
           <a:lstStyle/>
           <a:p>
-            <a:endParaRPr lang="en-US" dirty="0"/>
+            <a:pPr marL="171450" indent="-171450">
+              <a:buFontTx/>
+              <a:buChar char="-"/>
+            </a:pPr>
+            <a:r>
+              <a:rPr lang="en-US" dirty="0"/>
+              <a:t>Programs like Meshtastic and </a:t>
+            </a:r>
+            <a:r>
+              <a:rPr lang="en-US" dirty="0" err="1"/>
+              <a:t>meshcore</a:t>
+            </a:r>
+            <a:r>
+              <a:rPr lang="en-US" dirty="0"/>
+              <a:t> use LoRa to create a mesh network. This established long range communication between devices without the use of </a:t>
+            </a:r>
+            <a:r>
+              <a:rPr lang="en-US" dirty="0" err="1"/>
+              <a:t>WiFi</a:t>
+            </a:r>
+            <a:r>
+              <a:rPr lang="en-US" dirty="0"/>
+              <a:t> or Cellular data</a:t>
+            </a:r>
+          </a:p>
+          <a:p>
+            <a:pPr marL="171450" indent="-171450">
+              <a:buFontTx/>
+              <a:buChar char="-"/>
+            </a:pPr>
+            <a:r>
+              <a:rPr lang="en-US" dirty="0"/>
+              <a:t>Hobbyists love LoRa mesh technology because it does not require any certification</a:t>
+            </a:r>
+          </a:p>
+          <a:p>
+            <a:pPr marL="171450" indent="-171450">
+              <a:buFontTx/>
+              <a:buChar char="-"/>
+            </a:pPr>
+            <a:r>
+              <a:rPr lang="en-US" dirty="0"/>
+              <a:t>One of the most appealing use cases for LoRa meshes is a failsafe for </a:t>
+            </a:r>
+            <a:r>
+              <a:rPr lang="en-US" dirty="0" err="1"/>
+              <a:t>WiFi</a:t>
+            </a:r>
+            <a:r>
+              <a:rPr lang="en-US" dirty="0"/>
+              <a:t> and cellular in the case of an emergency, </a:t>
+            </a:r>
+            <a:r>
+              <a:rPr lang="en-US" dirty="0" err="1"/>
+              <a:t>likfe</a:t>
+            </a:r>
+            <a:r>
+              <a:rPr lang="en-US" dirty="0"/>
+              <a:t> natural disaster</a:t>
+            </a:r>
+          </a:p>
+          <a:p>
+            <a:pPr marL="171450" indent="-171450">
+              <a:buFontTx/>
+              <a:buChar char="-"/>
+            </a:pPr>
+            <a:r>
+              <a:rPr lang="en-US" dirty="0"/>
+              <a:t>It is also good for communication with others while ’off-grid’</a:t>
+            </a:r>
           </a:p>
         </p:txBody>
       </p:sp>
@@ -644,7 +1601,7 @@
           <a:p>
             <a:fld id="{96753925-02D2-5745-BCE6-069A285A2A4E}" type="slidenum">
               <a:rPr lang="en-US" smtClean="0"/>
-              <a:t>16</a:t>
+              <a:t>6</a:t>
             </a:fld>
             <a:endParaRPr lang="en-US"/>
           </a:p>
@@ -653,7 +1610,846 @@
     </p:spTree>
     <p:extLst>
       <p:ext uri="{BB962C8B-B14F-4D97-AF65-F5344CB8AC3E}">
-        <p14:creationId xmlns:p14="http://schemas.microsoft.com/office/powerpoint/2010/main" val="975279094"/>
+        <p14:creationId xmlns:p14="http://schemas.microsoft.com/office/powerpoint/2010/main" val="999409057"/>
+      </p:ext>
+    </p:extLst>
+  </p:cSld>
+  <p:clrMapOvr>
+    <a:masterClrMapping/>
+  </p:clrMapOvr>
+</p:notes>
+</file>
+
+<file path=ppt/notesSlides/notesSlide3.xml><?xml version="1.0" encoding="utf-8"?>
+<p:notes xmlns:a="http://schemas.openxmlformats.org/drawingml/2006/main" xmlns:r="http://schemas.openxmlformats.org/officeDocument/2006/relationships" xmlns:p="http://schemas.openxmlformats.org/presentationml/2006/main">
+  <p:cSld>
+    <p:spTree>
+      <p:nvGrpSpPr>
+        <p:cNvPr id="1" name=""/>
+        <p:cNvGrpSpPr/>
+        <p:nvPr/>
+      </p:nvGrpSpPr>
+      <p:grpSpPr>
+        <a:xfrm>
+          <a:off x="0" y="0"/>
+          <a:ext cx="0" cy="0"/>
+          <a:chOff x="0" y="0"/>
+          <a:chExt cx="0" cy="0"/>
+        </a:xfrm>
+      </p:grpSpPr>
+      <p:sp>
+        <p:nvSpPr>
+          <p:cNvPr id="2" name="Slide Image Placeholder 1"/>
+          <p:cNvSpPr>
+            <a:spLocks noGrp="1" noRot="1" noChangeAspect="1"/>
+          </p:cNvSpPr>
+          <p:nvPr>
+            <p:ph type="sldImg"/>
+          </p:nvPr>
+        </p:nvSpPr>
+        <p:spPr/>
+      </p:sp>
+      <p:sp>
+        <p:nvSpPr>
+          <p:cNvPr id="3" name="Notes Placeholder 2"/>
+          <p:cNvSpPr>
+            <a:spLocks noGrp="1"/>
+          </p:cNvSpPr>
+          <p:nvPr>
+            <p:ph type="body" idx="1"/>
+          </p:nvPr>
+        </p:nvSpPr>
+        <p:spPr/>
+        <p:txBody>
+          <a:bodyPr/>
+          <a:lstStyle/>
+          <a:p>
+            <a:pPr marL="171450" indent="-171450">
+              <a:buFontTx/>
+              <a:buChar char="-"/>
+            </a:pPr>
+            <a:r>
+              <a:rPr lang="en-US" dirty="0"/>
+              <a:t>The two main LoRa mesh ecosystems are Meshtastic and MeshCore</a:t>
+            </a:r>
+          </a:p>
+          <a:p>
+            <a:pPr marL="171450" indent="-171450">
+              <a:buFontTx/>
+              <a:buChar char="-"/>
+            </a:pPr>
+            <a:r>
+              <a:rPr lang="en-US" dirty="0"/>
+              <a:t>The two ecosystems do effectively the same thing, but they differ in architecture</a:t>
+            </a:r>
+          </a:p>
+          <a:p>
+            <a:pPr marL="171450" indent="-171450">
+              <a:buFontTx/>
+              <a:buChar char="-"/>
+            </a:pPr>
+            <a:r>
+              <a:rPr lang="en-US" dirty="0"/>
+              <a:t>Meshtastic uses a flood routing system to communicate, while MeshCore uses a more robust role-based multi-hop routing design. I will explain these more later</a:t>
+            </a:r>
+          </a:p>
+          <a:p>
+            <a:pPr marL="171450" indent="-171450">
+              <a:buFontTx/>
+              <a:buChar char="-"/>
+            </a:pPr>
+            <a:r>
+              <a:rPr lang="en-US" dirty="0"/>
+              <a:t>Each has its advantages depending on the use case</a:t>
+            </a:r>
+          </a:p>
+        </p:txBody>
+      </p:sp>
+      <p:sp>
+        <p:nvSpPr>
+          <p:cNvPr id="4" name="Slide Number Placeholder 3"/>
+          <p:cNvSpPr>
+            <a:spLocks noGrp="1"/>
+          </p:cNvSpPr>
+          <p:nvPr>
+            <p:ph type="sldNum" sz="quarter" idx="5"/>
+          </p:nvPr>
+        </p:nvSpPr>
+        <p:spPr/>
+        <p:txBody>
+          <a:bodyPr/>
+          <a:lstStyle/>
+          <a:p>
+            <a:fld id="{96753925-02D2-5745-BCE6-069A285A2A4E}" type="slidenum">
+              <a:rPr lang="en-US" smtClean="0"/>
+              <a:t>7</a:t>
+            </a:fld>
+            <a:endParaRPr lang="en-US"/>
+          </a:p>
+        </p:txBody>
+      </p:sp>
+    </p:spTree>
+    <p:extLst>
+      <p:ext uri="{BB962C8B-B14F-4D97-AF65-F5344CB8AC3E}">
+        <p14:creationId xmlns:p14="http://schemas.microsoft.com/office/powerpoint/2010/main" val="3467163027"/>
+      </p:ext>
+    </p:extLst>
+  </p:cSld>
+  <p:clrMapOvr>
+    <a:masterClrMapping/>
+  </p:clrMapOvr>
+</p:notes>
+</file>
+
+<file path=ppt/notesSlides/notesSlide4.xml><?xml version="1.0" encoding="utf-8"?>
+<p:notes xmlns:a="http://schemas.openxmlformats.org/drawingml/2006/main" xmlns:r="http://schemas.openxmlformats.org/officeDocument/2006/relationships" xmlns:p="http://schemas.openxmlformats.org/presentationml/2006/main">
+  <p:cSld>
+    <p:spTree>
+      <p:nvGrpSpPr>
+        <p:cNvPr id="1" name=""/>
+        <p:cNvGrpSpPr/>
+        <p:nvPr/>
+      </p:nvGrpSpPr>
+      <p:grpSpPr>
+        <a:xfrm>
+          <a:off x="0" y="0"/>
+          <a:ext cx="0" cy="0"/>
+          <a:chOff x="0" y="0"/>
+          <a:chExt cx="0" cy="0"/>
+        </a:xfrm>
+      </p:grpSpPr>
+      <p:sp>
+        <p:nvSpPr>
+          <p:cNvPr id="2" name="Slide Image Placeholder 1"/>
+          <p:cNvSpPr>
+            <a:spLocks noGrp="1" noRot="1" noChangeAspect="1"/>
+          </p:cNvSpPr>
+          <p:nvPr>
+            <p:ph type="sldImg"/>
+          </p:nvPr>
+        </p:nvSpPr>
+        <p:spPr/>
+      </p:sp>
+      <p:sp>
+        <p:nvSpPr>
+          <p:cNvPr id="3" name="Notes Placeholder 2"/>
+          <p:cNvSpPr>
+            <a:spLocks noGrp="1"/>
+          </p:cNvSpPr>
+          <p:nvPr>
+            <p:ph type="body" idx="1"/>
+          </p:nvPr>
+        </p:nvSpPr>
+        <p:spPr/>
+        <p:txBody>
+          <a:bodyPr/>
+          <a:lstStyle/>
+          <a:p>
+            <a:r>
+              <a:rPr lang="en-US" dirty="0"/>
+              <a:t>- Everything here we went over</a:t>
+            </a:r>
+          </a:p>
+          <a:p>
+            <a:r>
+              <a:rPr lang="en-US" dirty="0"/>
+              <a:t>- Because Meshtastic is older, it generally has a larger community and thus more support for different devices</a:t>
+            </a:r>
+          </a:p>
+        </p:txBody>
+      </p:sp>
+      <p:sp>
+        <p:nvSpPr>
+          <p:cNvPr id="4" name="Slide Number Placeholder 3"/>
+          <p:cNvSpPr>
+            <a:spLocks noGrp="1"/>
+          </p:cNvSpPr>
+          <p:nvPr>
+            <p:ph type="sldNum" sz="quarter" idx="5"/>
+          </p:nvPr>
+        </p:nvSpPr>
+        <p:spPr/>
+        <p:txBody>
+          <a:bodyPr/>
+          <a:lstStyle/>
+          <a:p>
+            <a:fld id="{96753925-02D2-5745-BCE6-069A285A2A4E}" type="slidenum">
+              <a:rPr lang="en-US" smtClean="0"/>
+              <a:t>8</a:t>
+            </a:fld>
+            <a:endParaRPr lang="en-US"/>
+          </a:p>
+        </p:txBody>
+      </p:sp>
+    </p:spTree>
+    <p:extLst>
+      <p:ext uri="{BB962C8B-B14F-4D97-AF65-F5344CB8AC3E}">
+        <p14:creationId xmlns:p14="http://schemas.microsoft.com/office/powerpoint/2010/main" val="2615278806"/>
+      </p:ext>
+    </p:extLst>
+  </p:cSld>
+  <p:clrMapOvr>
+    <a:masterClrMapping/>
+  </p:clrMapOvr>
+</p:notes>
+</file>
+
+<file path=ppt/notesSlides/notesSlide5.xml><?xml version="1.0" encoding="utf-8"?>
+<p:notes xmlns:a="http://schemas.openxmlformats.org/drawingml/2006/main" xmlns:r="http://schemas.openxmlformats.org/officeDocument/2006/relationships" xmlns:p="http://schemas.openxmlformats.org/presentationml/2006/main">
+  <p:cSld>
+    <p:spTree>
+      <p:nvGrpSpPr>
+        <p:cNvPr id="1" name=""/>
+        <p:cNvGrpSpPr/>
+        <p:nvPr/>
+      </p:nvGrpSpPr>
+      <p:grpSpPr>
+        <a:xfrm>
+          <a:off x="0" y="0"/>
+          <a:ext cx="0" cy="0"/>
+          <a:chOff x="0" y="0"/>
+          <a:chExt cx="0" cy="0"/>
+        </a:xfrm>
+      </p:grpSpPr>
+      <p:sp>
+        <p:nvSpPr>
+          <p:cNvPr id="2" name="Slide Image Placeholder 1"/>
+          <p:cNvSpPr>
+            <a:spLocks noGrp="1" noRot="1" noChangeAspect="1"/>
+          </p:cNvSpPr>
+          <p:nvPr>
+            <p:ph type="sldImg"/>
+          </p:nvPr>
+        </p:nvSpPr>
+        <p:spPr/>
+      </p:sp>
+      <p:sp>
+        <p:nvSpPr>
+          <p:cNvPr id="3" name="Notes Placeholder 2"/>
+          <p:cNvSpPr>
+            <a:spLocks noGrp="1"/>
+          </p:cNvSpPr>
+          <p:nvPr>
+            <p:ph type="body" idx="1"/>
+          </p:nvPr>
+        </p:nvSpPr>
+        <p:spPr/>
+        <p:txBody>
+          <a:bodyPr/>
+          <a:lstStyle/>
+          <a:p>
+            <a:pPr marL="171450" indent="-171450">
+              <a:buFontTx/>
+              <a:buChar char="-"/>
+            </a:pPr>
+            <a:r>
+              <a:rPr lang="en-US" dirty="0"/>
+              <a:t>Again, Meshtastic uses ‘managed flooding’</a:t>
+            </a:r>
+          </a:p>
+          <a:p>
+            <a:pPr marL="171450" indent="-171450">
+              <a:buFontTx/>
+              <a:buChar char="-"/>
+            </a:pPr>
+            <a:r>
+              <a:rPr lang="en-US" dirty="0"/>
+              <a:t>Managed flooding is a routing method where if a node hears a packet, it will automatically rebroadcast it either until:</a:t>
+            </a:r>
+          </a:p>
+          <a:p>
+            <a:pPr marL="628650" lvl="1" indent="-171450">
+              <a:buFontTx/>
+              <a:buChar char="-"/>
+            </a:pPr>
+            <a:r>
+              <a:rPr lang="en-US" dirty="0"/>
+              <a:t>The max hop count has been reached</a:t>
+            </a:r>
+          </a:p>
+          <a:p>
+            <a:pPr marL="628650" lvl="1" indent="-171450">
+              <a:buFontTx/>
+              <a:buChar char="-"/>
+            </a:pPr>
+            <a:r>
+              <a:rPr lang="en-US" dirty="0"/>
+              <a:t>The node has already been seen by the packet</a:t>
+            </a:r>
+          </a:p>
+          <a:p>
+            <a:pPr marL="171450" lvl="0" indent="-171450">
+              <a:buFontTx/>
+              <a:buChar char="-"/>
+            </a:pPr>
+            <a:r>
+              <a:rPr lang="en-US" dirty="0"/>
+              <a:t>With flooding, every node is both a sender and receiver. Every node is (in Meshtastic, almost) equal</a:t>
+            </a:r>
+          </a:p>
+          <a:p>
+            <a:pPr marL="171450" lvl="0" indent="-171450">
+              <a:buFontTx/>
+              <a:buChar char="-"/>
+            </a:pPr>
+            <a:r>
+              <a:rPr lang="en-US" dirty="0"/>
+              <a:t>It is also important note that Meshtastic prioritizes nodes that are further away </a:t>
+            </a:r>
+            <a:r>
+              <a:rPr lang="en-US" dirty="0" err="1"/>
+              <a:t>bu</a:t>
+            </a:r>
+            <a:r>
+              <a:rPr lang="en-US" dirty="0"/>
+              <a:t> making nodes with lower signal-to-noise ratio rebroadcast first to extend range.</a:t>
+            </a:r>
+          </a:p>
+        </p:txBody>
+      </p:sp>
+      <p:sp>
+        <p:nvSpPr>
+          <p:cNvPr id="4" name="Slide Number Placeholder 3"/>
+          <p:cNvSpPr>
+            <a:spLocks noGrp="1"/>
+          </p:cNvSpPr>
+          <p:nvPr>
+            <p:ph type="sldNum" sz="quarter" idx="5"/>
+          </p:nvPr>
+        </p:nvSpPr>
+        <p:spPr/>
+        <p:txBody>
+          <a:bodyPr/>
+          <a:lstStyle/>
+          <a:p>
+            <a:fld id="{96753925-02D2-5745-BCE6-069A285A2A4E}" type="slidenum">
+              <a:rPr lang="en-US" smtClean="0"/>
+              <a:t>9</a:t>
+            </a:fld>
+            <a:endParaRPr lang="en-US"/>
+          </a:p>
+        </p:txBody>
+      </p:sp>
+    </p:spTree>
+    <p:extLst>
+      <p:ext uri="{BB962C8B-B14F-4D97-AF65-F5344CB8AC3E}">
+        <p14:creationId xmlns:p14="http://schemas.microsoft.com/office/powerpoint/2010/main" val="3323988699"/>
+      </p:ext>
+    </p:extLst>
+  </p:cSld>
+  <p:clrMapOvr>
+    <a:masterClrMapping/>
+  </p:clrMapOvr>
+</p:notes>
+</file>
+
+<file path=ppt/notesSlides/notesSlide6.xml><?xml version="1.0" encoding="utf-8"?>
+<p:notes xmlns:a="http://schemas.openxmlformats.org/drawingml/2006/main" xmlns:r="http://schemas.openxmlformats.org/officeDocument/2006/relationships" xmlns:p="http://schemas.openxmlformats.org/presentationml/2006/main">
+  <p:cSld>
+    <p:spTree>
+      <p:nvGrpSpPr>
+        <p:cNvPr id="1" name=""/>
+        <p:cNvGrpSpPr/>
+        <p:nvPr/>
+      </p:nvGrpSpPr>
+      <p:grpSpPr>
+        <a:xfrm>
+          <a:off x="0" y="0"/>
+          <a:ext cx="0" cy="0"/>
+          <a:chOff x="0" y="0"/>
+          <a:chExt cx="0" cy="0"/>
+        </a:xfrm>
+      </p:grpSpPr>
+      <p:sp>
+        <p:nvSpPr>
+          <p:cNvPr id="2" name="Slide Image Placeholder 1"/>
+          <p:cNvSpPr>
+            <a:spLocks noGrp="1" noRot="1" noChangeAspect="1"/>
+          </p:cNvSpPr>
+          <p:nvPr>
+            <p:ph type="sldImg"/>
+          </p:nvPr>
+        </p:nvSpPr>
+        <p:spPr/>
+        <p:txBody>
+          <a:bodyPr/>
+          <a:lstStyle/>
+          <a:p>
+            <a:endParaRPr lang="en-US"/>
+          </a:p>
+        </p:txBody>
+      </p:sp>
+      <p:sp>
+        <p:nvSpPr>
+          <p:cNvPr id="3" name="Notes Placeholder 2"/>
+          <p:cNvSpPr>
+            <a:spLocks noGrp="1"/>
+          </p:cNvSpPr>
+          <p:nvPr>
+            <p:ph type="body" idx="1"/>
+          </p:nvPr>
+        </p:nvSpPr>
+        <p:spPr/>
+        <p:txBody>
+          <a:bodyPr/>
+          <a:lstStyle/>
+          <a:p>
+            <a:pPr marL="171450" indent="-171450">
+              <a:buFontTx/>
+              <a:buChar char="-"/>
+            </a:pPr>
+            <a:r>
+              <a:rPr lang="en-US" dirty="0"/>
+              <a:t>The only exception to managed flooding with Meshtastic is with direct messaging.</a:t>
+            </a:r>
+          </a:p>
+          <a:p>
+            <a:pPr marL="171450" indent="-171450">
+              <a:buFontTx/>
+              <a:buChar char="-"/>
+            </a:pPr>
+            <a:r>
+              <a:rPr lang="en-US" dirty="0"/>
+              <a:t>With DMs, the first message will flood. The receiving node will respond with an </a:t>
+            </a:r>
+            <a:r>
+              <a:rPr lang="en-US" dirty="0" err="1"/>
+              <a:t>ACKnowledgement</a:t>
+            </a:r>
+            <a:r>
+              <a:rPr lang="en-US" dirty="0"/>
+              <a:t> message, which includes logs showing which nodes relayed the packet. The device will now save the path, marking these nodes as next-hop and removing the need for more flooding.</a:t>
+            </a:r>
+          </a:p>
+        </p:txBody>
+      </p:sp>
+      <p:sp>
+        <p:nvSpPr>
+          <p:cNvPr id="4" name="Slide Number Placeholder 3"/>
+          <p:cNvSpPr>
+            <a:spLocks noGrp="1"/>
+          </p:cNvSpPr>
+          <p:nvPr>
+            <p:ph type="sldNum" sz="quarter" idx="5"/>
+          </p:nvPr>
+        </p:nvSpPr>
+        <p:spPr/>
+        <p:txBody>
+          <a:bodyPr/>
+          <a:lstStyle/>
+          <a:p>
+            <a:fld id="{96753925-02D2-5745-BCE6-069A285A2A4E}" type="slidenum">
+              <a:rPr lang="en-US" smtClean="0"/>
+              <a:t>10</a:t>
+            </a:fld>
+            <a:endParaRPr lang="en-US"/>
+          </a:p>
+        </p:txBody>
+      </p:sp>
+    </p:spTree>
+    <p:extLst>
+      <p:ext uri="{BB962C8B-B14F-4D97-AF65-F5344CB8AC3E}">
+        <p14:creationId xmlns:p14="http://schemas.microsoft.com/office/powerpoint/2010/main" val="702400172"/>
+      </p:ext>
+    </p:extLst>
+  </p:cSld>
+  <p:clrMapOvr>
+    <a:masterClrMapping/>
+  </p:clrMapOvr>
+</p:notes>
+</file>
+
+<file path=ppt/notesSlides/notesSlide7.xml><?xml version="1.0" encoding="utf-8"?>
+<p:notes xmlns:a="http://schemas.openxmlformats.org/drawingml/2006/main" xmlns:r="http://schemas.openxmlformats.org/officeDocument/2006/relationships" xmlns:p="http://schemas.openxmlformats.org/presentationml/2006/main">
+  <p:cSld>
+    <p:spTree>
+      <p:nvGrpSpPr>
+        <p:cNvPr id="1" name=""/>
+        <p:cNvGrpSpPr/>
+        <p:nvPr/>
+      </p:nvGrpSpPr>
+      <p:grpSpPr>
+        <a:xfrm>
+          <a:off x="0" y="0"/>
+          <a:ext cx="0" cy="0"/>
+          <a:chOff x="0" y="0"/>
+          <a:chExt cx="0" cy="0"/>
+        </a:xfrm>
+      </p:grpSpPr>
+      <p:sp>
+        <p:nvSpPr>
+          <p:cNvPr id="2" name="Slide Image Placeholder 1"/>
+          <p:cNvSpPr>
+            <a:spLocks noGrp="1" noRot="1" noChangeAspect="1"/>
+          </p:cNvSpPr>
+          <p:nvPr>
+            <p:ph type="sldImg"/>
+          </p:nvPr>
+        </p:nvSpPr>
+        <p:spPr/>
+      </p:sp>
+      <p:sp>
+        <p:nvSpPr>
+          <p:cNvPr id="3" name="Notes Placeholder 2"/>
+          <p:cNvSpPr>
+            <a:spLocks noGrp="1"/>
+          </p:cNvSpPr>
+          <p:nvPr>
+            <p:ph type="body" idx="1"/>
+          </p:nvPr>
+        </p:nvSpPr>
+        <p:spPr/>
+        <p:txBody>
+          <a:bodyPr/>
+          <a:lstStyle/>
+          <a:p>
+            <a:pPr marL="171450" indent="-171450">
+              <a:buFontTx/>
+              <a:buChar char="-"/>
+            </a:pPr>
+            <a:r>
+              <a:rPr lang="en-US" dirty="0"/>
+              <a:t>Meshtastic provides plenty of LoRa configuration settings to fine tune performance</a:t>
+            </a:r>
+          </a:p>
+          <a:p>
+            <a:pPr marL="171450" indent="-171450">
+              <a:buFontTx/>
+              <a:buChar char="-"/>
+            </a:pPr>
+            <a:r>
+              <a:rPr lang="en-US" dirty="0"/>
+              <a:t>It is important to make sure that the region and modem presets between nodes are the same or else communication will not work</a:t>
+            </a:r>
+          </a:p>
+        </p:txBody>
+      </p:sp>
+      <p:sp>
+        <p:nvSpPr>
+          <p:cNvPr id="4" name="Slide Number Placeholder 3"/>
+          <p:cNvSpPr>
+            <a:spLocks noGrp="1"/>
+          </p:cNvSpPr>
+          <p:nvPr>
+            <p:ph type="sldNum" sz="quarter" idx="5"/>
+          </p:nvPr>
+        </p:nvSpPr>
+        <p:spPr/>
+        <p:txBody>
+          <a:bodyPr/>
+          <a:lstStyle/>
+          <a:p>
+            <a:fld id="{96753925-02D2-5745-BCE6-069A285A2A4E}" type="slidenum">
+              <a:rPr lang="en-US" smtClean="0"/>
+              <a:t>11</a:t>
+            </a:fld>
+            <a:endParaRPr lang="en-US"/>
+          </a:p>
+        </p:txBody>
+      </p:sp>
+    </p:spTree>
+    <p:extLst>
+      <p:ext uri="{BB962C8B-B14F-4D97-AF65-F5344CB8AC3E}">
+        <p14:creationId xmlns:p14="http://schemas.microsoft.com/office/powerpoint/2010/main" val="3047218706"/>
+      </p:ext>
+    </p:extLst>
+  </p:cSld>
+  <p:clrMapOvr>
+    <a:masterClrMapping/>
+  </p:clrMapOvr>
+</p:notes>
+</file>
+
+<file path=ppt/notesSlides/notesSlide8.xml><?xml version="1.0" encoding="utf-8"?>
+<p:notes xmlns:a="http://schemas.openxmlformats.org/drawingml/2006/main" xmlns:r="http://schemas.openxmlformats.org/officeDocument/2006/relationships" xmlns:p="http://schemas.openxmlformats.org/presentationml/2006/main">
+  <p:cSld>
+    <p:spTree>
+      <p:nvGrpSpPr>
+        <p:cNvPr id="1" name=""/>
+        <p:cNvGrpSpPr/>
+        <p:nvPr/>
+      </p:nvGrpSpPr>
+      <p:grpSpPr>
+        <a:xfrm>
+          <a:off x="0" y="0"/>
+          <a:ext cx="0" cy="0"/>
+          <a:chOff x="0" y="0"/>
+          <a:chExt cx="0" cy="0"/>
+        </a:xfrm>
+      </p:grpSpPr>
+      <p:sp>
+        <p:nvSpPr>
+          <p:cNvPr id="2" name="Slide Image Placeholder 1"/>
+          <p:cNvSpPr>
+            <a:spLocks noGrp="1" noRot="1" noChangeAspect="1"/>
+          </p:cNvSpPr>
+          <p:nvPr>
+            <p:ph type="sldImg"/>
+          </p:nvPr>
+        </p:nvSpPr>
+        <p:spPr/>
+      </p:sp>
+      <p:sp>
+        <p:nvSpPr>
+          <p:cNvPr id="3" name="Notes Placeholder 2"/>
+          <p:cNvSpPr>
+            <a:spLocks noGrp="1"/>
+          </p:cNvSpPr>
+          <p:nvPr>
+            <p:ph type="body" idx="1"/>
+          </p:nvPr>
+        </p:nvSpPr>
+        <p:spPr/>
+        <p:txBody>
+          <a:bodyPr/>
+          <a:lstStyle/>
+          <a:p>
+            <a:pPr marL="171450" indent="-171450">
+              <a:buFontTx/>
+              <a:buChar char="-"/>
+            </a:pPr>
+            <a:r>
+              <a:rPr lang="en-US" dirty="0"/>
+              <a:t>Like I said before, MeshCore is just like Meshtastic in its function, but differs in architecture</a:t>
+            </a:r>
+          </a:p>
+          <a:p>
+            <a:pPr marL="171450" indent="-171450">
+              <a:buFontTx/>
+              <a:buChar char="-"/>
+            </a:pPr>
+            <a:r>
+              <a:rPr lang="en-US" dirty="0"/>
+              <a:t>Very similarly to Meshtastic, it uses next-hop routing (like Meshtastic DMs) for direct messages and flood routing for group and public messages</a:t>
+            </a:r>
+          </a:p>
+          <a:p>
+            <a:pPr marL="171450" indent="-171450">
+              <a:buFontTx/>
+              <a:buChar char="-"/>
+            </a:pPr>
+            <a:r>
+              <a:rPr lang="en-US" dirty="0"/>
+              <a:t>The main difference is in the roles. With Meshtastic, EVERY node will rebroadcast messages across the mesh. With MeshCore, not every node will rebroadcast – only repeater nodes will rebroadcast.</a:t>
+            </a:r>
+          </a:p>
+          <a:p>
+            <a:pPr marL="171450" indent="-171450">
+              <a:buFontTx/>
+              <a:buChar char="-"/>
+            </a:pPr>
+            <a:r>
+              <a:rPr lang="en-US" dirty="0"/>
+              <a:t>This prevents wasted airtime and communication, but makes MeshCore more reliant on infrastructure</a:t>
+            </a:r>
+          </a:p>
+          <a:p>
+            <a:pPr marL="171450" indent="-171450">
+              <a:buFontTx/>
+              <a:buChar char="-"/>
+            </a:pPr>
+            <a:endParaRPr lang="en-US" dirty="0"/>
+          </a:p>
+          <a:p>
+            <a:pPr marL="171450" indent="-171450">
+              <a:buFontTx/>
+              <a:buChar char="-"/>
+            </a:pPr>
+            <a:endParaRPr lang="en-US" dirty="0"/>
+          </a:p>
+        </p:txBody>
+      </p:sp>
+      <p:sp>
+        <p:nvSpPr>
+          <p:cNvPr id="4" name="Slide Number Placeholder 3"/>
+          <p:cNvSpPr>
+            <a:spLocks noGrp="1"/>
+          </p:cNvSpPr>
+          <p:nvPr>
+            <p:ph type="sldNum" sz="quarter" idx="5"/>
+          </p:nvPr>
+        </p:nvSpPr>
+        <p:spPr/>
+        <p:txBody>
+          <a:bodyPr/>
+          <a:lstStyle/>
+          <a:p>
+            <a:fld id="{96753925-02D2-5745-BCE6-069A285A2A4E}" type="slidenum">
+              <a:rPr lang="en-US" smtClean="0"/>
+              <a:t>12</a:t>
+            </a:fld>
+            <a:endParaRPr lang="en-US"/>
+          </a:p>
+        </p:txBody>
+      </p:sp>
+    </p:spTree>
+    <p:extLst>
+      <p:ext uri="{BB962C8B-B14F-4D97-AF65-F5344CB8AC3E}">
+        <p14:creationId xmlns:p14="http://schemas.microsoft.com/office/powerpoint/2010/main" val="801610102"/>
+      </p:ext>
+    </p:extLst>
+  </p:cSld>
+  <p:clrMapOvr>
+    <a:masterClrMapping/>
+  </p:clrMapOvr>
+</p:notes>
+</file>
+
+<file path=ppt/notesSlides/notesSlide9.xml><?xml version="1.0" encoding="utf-8"?>
+<p:notes xmlns:a="http://schemas.openxmlformats.org/drawingml/2006/main" xmlns:r="http://schemas.openxmlformats.org/officeDocument/2006/relationships" xmlns:p="http://schemas.openxmlformats.org/presentationml/2006/main">
+  <p:cSld>
+    <p:spTree>
+      <p:nvGrpSpPr>
+        <p:cNvPr id="1" name=""/>
+        <p:cNvGrpSpPr/>
+        <p:nvPr/>
+      </p:nvGrpSpPr>
+      <p:grpSpPr>
+        <a:xfrm>
+          <a:off x="0" y="0"/>
+          <a:ext cx="0" cy="0"/>
+          <a:chOff x="0" y="0"/>
+          <a:chExt cx="0" cy="0"/>
+        </a:xfrm>
+      </p:grpSpPr>
+      <p:sp>
+        <p:nvSpPr>
+          <p:cNvPr id="2" name="Slide Image Placeholder 1"/>
+          <p:cNvSpPr>
+            <a:spLocks noGrp="1" noRot="1" noChangeAspect="1"/>
+          </p:cNvSpPr>
+          <p:nvPr>
+            <p:ph type="sldImg"/>
+          </p:nvPr>
+        </p:nvSpPr>
+        <p:spPr/>
+      </p:sp>
+      <p:sp>
+        <p:nvSpPr>
+          <p:cNvPr id="3" name="Notes Placeholder 2"/>
+          <p:cNvSpPr>
+            <a:spLocks noGrp="1"/>
+          </p:cNvSpPr>
+          <p:nvPr>
+            <p:ph type="body" idx="1"/>
+          </p:nvPr>
+        </p:nvSpPr>
+        <p:spPr/>
+        <p:txBody>
+          <a:bodyPr/>
+          <a:lstStyle/>
+          <a:p>
+            <a:pPr marL="171450" indent="-171450">
+              <a:buFontTx/>
+              <a:buChar char="-"/>
+            </a:pPr>
+            <a:r>
+              <a:rPr lang="en-US" dirty="0"/>
+              <a:t>As stated previously, MeshCore requires each device to have a role, those being companions, repeaters and room server</a:t>
+            </a:r>
+          </a:p>
+          <a:p>
+            <a:pPr marL="171450" marR="0" lvl="0" indent="-171450" algn="l" defTabSz="914400" rtl="0" eaLnBrk="1" fontAlgn="auto" latinLnBrk="0" hangingPunct="1">
+              <a:lnSpc>
+                <a:spcPct val="100000"/>
+              </a:lnSpc>
+              <a:spcBef>
+                <a:spcPts val="0"/>
+              </a:spcBef>
+              <a:spcAft>
+                <a:spcPts val="0"/>
+              </a:spcAft>
+              <a:buClrTx/>
+              <a:buSzTx/>
+              <a:buFontTx/>
+              <a:buChar char="-"/>
+              <a:tabLst/>
+              <a:defRPr/>
+            </a:pPr>
+            <a:r>
+              <a:rPr lang="en-US" dirty="0"/>
+              <a:t>Companion devices connect to your phone and are used to send and receive messages. Repeater devices’ main purpose is to rebroadcast packets.</a:t>
+            </a:r>
+          </a:p>
+          <a:p>
+            <a:pPr marL="171450" indent="-171450">
+              <a:buFontTx/>
+              <a:buChar char="-"/>
+            </a:pPr>
+            <a:r>
+              <a:rPr lang="en-US" dirty="0"/>
+              <a:t>One downside to next-hop routing and path learning is that is a repeater is moved, the route will break and will have to be relearned. This makes Meshtastic better for communication between people constantly moving around off the grid.</a:t>
+            </a:r>
+          </a:p>
+        </p:txBody>
+      </p:sp>
+      <p:sp>
+        <p:nvSpPr>
+          <p:cNvPr id="4" name="Slide Number Placeholder 3"/>
+          <p:cNvSpPr>
+            <a:spLocks noGrp="1"/>
+          </p:cNvSpPr>
+          <p:nvPr>
+            <p:ph type="sldNum" sz="quarter" idx="5"/>
+          </p:nvPr>
+        </p:nvSpPr>
+        <p:spPr/>
+        <p:txBody>
+          <a:bodyPr/>
+          <a:lstStyle/>
+          <a:p>
+            <a:fld id="{96753925-02D2-5745-BCE6-069A285A2A4E}" type="slidenum">
+              <a:rPr lang="en-US" smtClean="0"/>
+              <a:t>13</a:t>
+            </a:fld>
+            <a:endParaRPr lang="en-US"/>
+          </a:p>
+        </p:txBody>
+      </p:sp>
+    </p:spTree>
+    <p:extLst>
+      <p:ext uri="{BB962C8B-B14F-4D97-AF65-F5344CB8AC3E}">
+        <p14:creationId xmlns:p14="http://schemas.microsoft.com/office/powerpoint/2010/main" val="1259206706"/>
       </p:ext>
     </p:extLst>
   </p:cSld>
@@ -5000,7 +6796,7 @@
             </a:r>
             <a:r>
               <a:rPr lang="en-US" dirty="0">
-                <a:hlinkClick r:id="rId2"/>
+                <a:hlinkClick r:id="rId3"/>
               </a:rPr>
               <a:t>Meshtastic website </a:t>
             </a:r>
@@ -5234,7 +7030,7 @@
             </a:r>
             <a:r>
               <a:rPr lang="en-US" dirty="0">
-                <a:hlinkClick r:id="rId2"/>
+                <a:hlinkClick r:id="rId3"/>
               </a:rPr>
               <a:t>MeshCore main site</a:t>
             </a:r>
@@ -5258,7 +7054,7 @@
           <a:p>
             <a:r>
               <a:rPr lang="en-US" dirty="0">
-                <a:hlinkClick r:id="rId3"/>
+                <a:hlinkClick r:id="rId4"/>
               </a:rPr>
               <a:t>This document </a:t>
             </a:r>
@@ -5356,7 +7152,7 @@
             </a:r>
             <a:r>
               <a:rPr lang="en-US" dirty="0">
-                <a:hlinkClick r:id="rId2"/>
+                <a:hlinkClick r:id="rId3"/>
               </a:rPr>
               <a:t>Meshtastic web flasher</a:t>
             </a:r>
@@ -5372,7 +7168,7 @@
             </a:r>
             <a:r>
               <a:rPr lang="en-US" dirty="0">
-                <a:hlinkClick r:id="rId3"/>
+                <a:hlinkClick r:id="rId4"/>
               </a:rPr>
               <a:t>web flasher</a:t>
             </a:r>
@@ -5480,7 +7276,7 @@
             </a:r>
             <a:r>
               <a:rPr lang="en-US" dirty="0">
-                <a:hlinkClick r:id="rId2"/>
+                <a:hlinkClick r:id="rId3"/>
               </a:rPr>
               <a:t>Meshtastic GitHub</a:t>
             </a:r>
@@ -5496,7 +7292,7 @@
             </a:r>
             <a:r>
               <a:rPr lang="en-US" dirty="0">
-                <a:hlinkClick r:id="rId3"/>
+                <a:hlinkClick r:id="rId4"/>
               </a:rPr>
               <a:t>MeshCore GitHub</a:t>
             </a:r>
@@ -5596,7 +7392,7 @@
           <a:p>
             <a:r>
               <a:rPr lang="en-US" b="1" dirty="0">
-                <a:hlinkClick r:id="rId2"/>
+                <a:hlinkClick r:id="rId3"/>
               </a:rPr>
               <a:t>dev.to – First message in 30 minutes</a:t>
             </a:r>
@@ -5619,7 +7415,7 @@
           <a:p>
             <a:r>
               <a:rPr lang="en-US" b="1" dirty="0">
-                <a:hlinkClick r:id="rId3"/>
+                <a:hlinkClick r:id="rId4"/>
               </a:rPr>
               <a:t>Austin Mesh – Getting Started with MeshCore</a:t>
             </a:r>
@@ -5642,7 +7438,7 @@
           <a:p>
             <a:r>
               <a:rPr lang="en-US" b="1" dirty="0">
-                <a:hlinkClick r:id="rId4"/>
+                <a:hlinkClick r:id="rId5"/>
               </a:rPr>
               <a:t>Kindlymorrow – What is MeshCore</a:t>
             </a:r>
@@ -5747,7 +7543,7 @@
           <a:p>
             <a:r>
               <a:rPr lang="en-CA" b="1" dirty="0">
-                <a:hlinkClick r:id="rId2"/>
+                <a:hlinkClick r:id="rId3"/>
               </a:rPr>
               <a:t>How to Set Up Meshtastic (Step-by-Step Guide for Beginners)</a:t>
             </a:r>
@@ -5759,29 +7555,29 @@
               <a:rPr lang="en-CA" dirty="0"/>
               <a:t>Great video for setting up devices and using Meshtastic for the first time.</a:t>
             </a:r>
-          </a:p>
-          <a:p>
-            <a:r>
-              <a:rPr lang="en-CA" b="1" dirty="0">
-                <a:hlinkClick r:id="rId3"/>
-              </a:rPr>
-              <a:t>Web Firmware / Configuration Guide - LILYGO Meshtastic T-Beam V1.1 ESP32 Wireless Module</a:t>
-            </a:r>
-            <a:endParaRPr lang="en-CA" b="1" dirty="0"/>
-          </a:p>
-          <a:p>
-            <a:pPr lvl="1"/>
-            <a:r>
-              <a:rPr lang="en-CA" dirty="0"/>
-              <a:t>Best video for showing how to use Meshtastic with the web client.</a:t>
-            </a:r>
-            <a:endParaRPr lang="en-CA" b="1" dirty="0"/>
           </a:p>
           <a:p>
             <a:r>
               <a:rPr lang="en-CA" b="1" dirty="0">
                 <a:hlinkClick r:id="rId4"/>
               </a:rPr>
+              <a:t>Web Firmware / Configuration Guide - LILYGO Meshtastic T-Beam V1.1 ESP32 Wireless Module</a:t>
+            </a:r>
+            <a:endParaRPr lang="en-CA" b="1" dirty="0"/>
+          </a:p>
+          <a:p>
+            <a:pPr lvl="1"/>
+            <a:r>
+              <a:rPr lang="en-CA" dirty="0"/>
+              <a:t>Best video for showing how to use Meshtastic with the web client.</a:t>
+            </a:r>
+            <a:endParaRPr lang="en-CA" b="1" dirty="0"/>
+          </a:p>
+          <a:p>
+            <a:r>
+              <a:rPr lang="en-CA" b="1" dirty="0">
+                <a:hlinkClick r:id="rId5"/>
+              </a:rPr>
               <a:t>How to Flash a MeshCore Repeater</a:t>
             </a:r>
             <a:endParaRPr lang="en-CA" b="1" dirty="0"/>
@@ -5796,7 +7592,7 @@
           <a:p>
             <a:r>
               <a:rPr lang="en-CA" b="1" dirty="0">
-                <a:hlinkClick r:id="rId5"/>
+                <a:hlinkClick r:id="rId6"/>
               </a:rPr>
               <a:t>465 Rutgers University Confirmed: Meshtastic and LoRa are dangerous</a:t>
             </a:r>

</xml_diff>

<commit_message>
Updated script to receive telemetry packets
</commit_message>
<xml_diff>
--- a/week1readings.pptx
+++ b/week1readings.pptx
@@ -1419,11 +1419,7 @@
             </a:pPr>
             <a:r>
               <a:rPr lang="en-US" dirty="0"/>
-              <a:t>The Meshtastic and LoRa are dangerous video was a great watch. It begun explaining meshes and LoRa at a high level, slowly diving into Meshtastic specifics like how Meshtastic takes advantage of MQTT servers and integrating sensors into </a:t>
-            </a:r>
-            <a:r>
-              <a:rPr lang="en-US"/>
-              <a:t>the mesh.</a:t>
+              <a:t>The Meshtastic and LoRa are dangerous video was a great watch. It begun explaining meshes and LoRa at a high level, slowly diving into Meshtastic specifics like how Meshtastic takes advantage of MQTT servers and integrating sensors into the mesh.</a:t>
             </a:r>
           </a:p>
           <a:p>

</xml_diff>